<commit_message>
Correct lesson 10's receptive field and show its 2.5 sigma
Section 4.2 said a 3x3 kernel after pooling covers 6x6 of the original
image; in this architecture the first 3x3 layer sits beneath it, so it is
6 + 2 = 8, an 8x8 window, now counted in the handout and corrected on the
slide. Section 1.1 called the batch's 2.55% error rate "2.5 standard
deviations high" without the arithmetic; the binomial sd over 4,000 dies,
0.0022, is now shown.

Also repairs the formula the previous notes commit broke: a regex
replacement turned the \t of \times into a tab, so the handout read "32 imes
(9 imes 16)". worked_examples.py now checks the sd and the receptive field.
No figure is added; the lesson already draws each of its arguments.

Co-Authored-By: Claude Opus 5.5 <noreply@anthropic.com>
</commit_message>
<xml_diff>
--- a/Lessons/10_convolutional_networks/Slides/convolutional_networks_slides.pptx
+++ b/Lessons/10_convolutional_networks/Slides/convolutional_networks_slides.pptx
@@ -3562,7 +3562,21 @@
             </a:pPr>
             <a:r>
               <a:rPr/>
-              <a:t>Invariance is the goal here: after pooling, moving the defect by a pixel often produces a literally identical output. Receptive field growth is the reason depth works at all - stack pooling and small kernels and a 3×3 window at layer four sees most of the die, for nine weights. Precision loss is the bill.</a:t>
+              <a:t>Invariance is the goal here: after pooling, moving the defect by a pixel often produces a literally identical output.</a:t>
+            </a:r>
+          </a:p>
+          <a:p>
+            <a:pPr lvl="0" indent="0" marL="0">
+              <a:buNone/>
+            </a:pPr>
+          </a:p>
+          <a:p>
+            <a:pPr lvl="0" indent="0" marL="0">
+              <a:buNone/>
+            </a:pPr>
+            <a:r>
+              <a:rPr/>
+              <a:t>On the receptive field, count it once with them: a 3×3 kernel after a 2×2 pooling spans 6×6 of the map it pooled, and the first 3×3 layer underneath adds one pixel on each side, so 8×8 of the image. Handout section 4.2. Receptive field growth is the reason depth works at all - stack pooling and small kernels and a 3×3 window at layer four sees most of the die, for nine weights. Precision loss is the bill.</a:t>
             </a:r>
           </a:p>
           <a:p>
@@ -14294,7 +14308,7 @@
             <a:pPr lvl="0"/>
             <a:r>
               <a:rPr/>
-              <a:t>Enlarges the receptive field: 3×3 after pooling covers 6×6 of the image</a:t>
+              <a:t>Enlarges the receptive field: 3×3 after pooling covers 8×8 of the image</a:t>
             </a:r>
           </a:p>
           <a:p>

</xml_diff>

<commit_message>
Rewrite lesson 9 lighter: one hidden layer, MLPClassifier and Keras
The first lesson 9 (matrix backpropagation, initialisation variance, a
seven-hour notebook) is kept in Advanced/ for a later course. The new one
has more figures and less mathematics: a hidden layer drawn line by line
on the sensor data, a Keras network on the digits, and training in
practice. Its number to remember is 39 against 2.8: what one hidden layer
is worth where inputs act together, and where they act alone (the 2.8 is
split-dependent, 4.7 on another split, and every artefact says so).

Lesson 10, the syllabus, the bridge and CLAUDE.md's number table follow.

Co-Authored-By: Claude Opus 5.5 <noreply@anthropic.com>
</commit_message>
<xml_diff>
--- a/Lessons/10_convolutional_networks/Slides/convolutional_networks_slides.pptx
+++ b/Lessons/10_convolutional_networks/Slides/convolutional_networks_slides.pptx
@@ -7716,7 +7716,7 @@
             </a:pPr>
             <a:r>
               <a:rPr/>
-              <a:t>The point of the list is not nostalgia. Each of these numbers was a surprise to somebody who had the correct general principle already: leakage is bad, imputation must sit inside the fold, regularisation controls coefficients, anomalies are relational, sigmoids attenuate gradients. Knowing the principle did not protect anyone. Seeing the number did.</a:t>
+              <a:t>The point of the list is not nostalgia. Each of these numbers was a surprise to somebody who had the correct general principle already: leakage is bad, imputation must sit inside the fold, regularisation controls coefficients, anomalies are relational, depth pays only when inputs act together. Knowing the principle did not protect anyone. Seeing the number did.</a:t>
             </a:r>
           </a:p>
           <a:p>
@@ -19219,7 +19219,7 @@
             <a:pPr lvl="0"/>
             <a:r>
               <a:rPr/>
-              <a:t>Lesson 9: a hidden layer worth 39 points on one problem, 0.09 on another</a:t>
+              <a:t>Lesson 9: a hidden layer worth 39 points on one problem, 2.8 on another</a:t>
             </a:r>
           </a:p>
           <a:p>
@@ -19717,11 +19717,23 @@
             <a:pPr lvl="0"/>
             <a:r>
               <a:rPr/>
-              <a:t>A sigmoid layer divides the gradient by about </a:t>
+              <a:t>A hidden layer: worth </a:t>
             </a:r>
             <a:r>
               <a:rPr b="1"/>
-              <a:t>four</a:t>
+              <a:t>39</a:t>
+            </a:r>
+            <a:r>
+              <a:rPr/>
+              <a:t> points on one problem, </a:t>
+            </a:r>
+            <a:r>
+              <a:rPr b="1"/>
+              <a:t>2.8</a:t>
+            </a:r>
+            <a:r>
+              <a:rPr/>
+              <a:t> on another</a:t>
             </a:r>
           </a:p>
         </p:txBody>

</xml_diff>